<commit_message>
fix(ppt): 幻灯片尺寸 960x540 → 1280x720pt 修内容溢出
审计发现所有 19 张 slide 的坐标都基于 ~1200pt 宽 / ~680pt 高的假设
编写，但 theme.py 里 SLIDE_WIDTH=960pt / SLIDE_HEIGHT=540pt 导致
10+ 个 shape 横向溢出、5+ 个纵向溢出。

改为 1280x720pt（17.78"x10"，仍 16:9），原设计坐标基本全部合进去，
不用改任何 slide 文件。审计后零溢出。
</commit_message>
<xml_diff>
--- a/ppt/output/学习智能体系统_汇报PPT.pptx
+++ b/ppt/output/学习智能体系统_汇报PPT.pptx
@@ -25,7 +25,7 @@
     <p:sldId id="273" r:id="rId24"/>
     <p:sldId id="274" r:id="rId25"/>
   </p:sldIdLst>
-  <p:sldSz cx="12192000" cy="6858000" type="screen4x3"/>
+  <p:sldSz cx="16256000" cy="9144000" type="screen4x3"/>
   <p:notesSz cx="6858000" cy="9144000"/>
   <p:defaultTextStyle>
     <a:defPPr>
@@ -3115,7 +3115,7 @@
         <p:spPr>
           <a:xfrm>
             <a:off x="0" y="0"/>
-            <a:ext cx="76200" cy="6858000"/>
+            <a:ext cx="76200" cy="9144000"/>
           </a:xfrm>
           <a:prstGeom prst="rect">
             <a:avLst/>
@@ -3159,7 +3159,7 @@
         <p:spPr>
           <a:xfrm>
             <a:off x="76200" y="0"/>
-            <a:ext cx="50800" cy="6858000"/>
+            <a:ext cx="50800" cy="9144000"/>
           </a:xfrm>
           <a:prstGeom prst="rect">
             <a:avLst/>
@@ -3386,7 +3386,7 @@
         </p:nvSpPr>
         <p:spPr>
           <a:xfrm>
-            <a:off x="508000" y="4318000"/>
+            <a:off x="508000" y="6604000"/>
             <a:ext cx="1016000" cy="304800"/>
           </a:xfrm>
           <a:prstGeom prst="rect">
@@ -3421,7 +3421,7 @@
         </p:nvSpPr>
         <p:spPr>
           <a:xfrm>
-            <a:off x="1524000" y="4318000"/>
+            <a:off x="1524000" y="6604000"/>
             <a:ext cx="5080000" cy="304800"/>
           </a:xfrm>
           <a:prstGeom prst="rect">
@@ -3456,7 +3456,7 @@
         </p:nvSpPr>
         <p:spPr>
           <a:xfrm>
-            <a:off x="508000" y="4673600"/>
+            <a:off x="508000" y="6959600"/>
             <a:ext cx="1016000" cy="304800"/>
           </a:xfrm>
           <a:prstGeom prst="rect">
@@ -3491,7 +3491,7 @@
         </p:nvSpPr>
         <p:spPr>
           <a:xfrm>
-            <a:off x="1524000" y="4673600"/>
+            <a:off x="1524000" y="6959600"/>
             <a:ext cx="5080000" cy="304800"/>
           </a:xfrm>
           <a:prstGeom prst="rect">
@@ -3526,7 +3526,7 @@
         </p:nvSpPr>
         <p:spPr>
           <a:xfrm>
-            <a:off x="508000" y="5029200"/>
+            <a:off x="508000" y="7315200"/>
             <a:ext cx="1016000" cy="304800"/>
           </a:xfrm>
           <a:prstGeom prst="rect">
@@ -3561,7 +3561,7 @@
         </p:nvSpPr>
         <p:spPr>
           <a:xfrm>
-            <a:off x="1524000" y="5029200"/>
+            <a:off x="1524000" y="7315200"/>
             <a:ext cx="5080000" cy="304800"/>
           </a:xfrm>
           <a:prstGeom prst="rect">
@@ -3596,7 +3596,7 @@
         </p:nvSpPr>
         <p:spPr>
           <a:xfrm>
-            <a:off x="508000" y="5384800"/>
+            <a:off x="508000" y="7670800"/>
             <a:ext cx="1016000" cy="304800"/>
           </a:xfrm>
           <a:prstGeom prst="rect">
@@ -3631,7 +3631,7 @@
         </p:nvSpPr>
         <p:spPr>
           <a:xfrm>
-            <a:off x="1524000" y="5384800"/>
+            <a:off x="1524000" y="7670800"/>
             <a:ext cx="5080000" cy="304800"/>
           </a:xfrm>
           <a:prstGeom prst="rect">
@@ -3666,7 +3666,7 @@
         </p:nvSpPr>
         <p:spPr>
           <a:xfrm>
-            <a:off x="508000" y="5740400"/>
+            <a:off x="508000" y="8026400"/>
             <a:ext cx="1016000" cy="304800"/>
           </a:xfrm>
           <a:prstGeom prst="rect">
@@ -3701,7 +3701,7 @@
         </p:nvSpPr>
         <p:spPr>
           <a:xfrm>
-            <a:off x="1524000" y="5740400"/>
+            <a:off x="1524000" y="8026400"/>
             <a:ext cx="5080000" cy="304800"/>
           </a:xfrm>
           <a:prstGeom prst="rect">
@@ -3736,7 +3736,7 @@
         </p:nvSpPr>
         <p:spPr>
           <a:xfrm>
-            <a:off x="10160000" y="4826000"/>
+            <a:off x="14224000" y="7112000"/>
             <a:ext cx="1524000" cy="1524000"/>
           </a:xfrm>
           <a:prstGeom prst="rect">
@@ -3780,7 +3780,7 @@
         </p:nvSpPr>
         <p:spPr>
           <a:xfrm>
-            <a:off x="10160000" y="5207000"/>
+            <a:off x="14224000" y="7493000"/>
             <a:ext cx="1524000" cy="762000"/>
           </a:xfrm>
           <a:prstGeom prst="rect">
@@ -3869,7 +3869,7 @@
         </p:nvSpPr>
         <p:spPr>
           <a:xfrm>
-            <a:off x="8890000" y="254000"/>
+            <a:off x="12954000" y="254000"/>
             <a:ext cx="2540000" cy="304800"/>
           </a:xfrm>
           <a:prstGeom prst="rect">
@@ -3905,7 +3905,7 @@
         <p:spPr>
           <a:xfrm>
             <a:off x="0" y="635000"/>
-            <a:ext cx="50800" cy="5588000"/>
+            <a:ext cx="50800" cy="7874000"/>
           </a:xfrm>
           <a:prstGeom prst="rect">
             <a:avLst/>
@@ -3948,7 +3948,7 @@
         </p:nvSpPr>
         <p:spPr>
           <a:xfrm>
-            <a:off x="762000" y="6413500"/>
+            <a:off x="762000" y="8699500"/>
             <a:ext cx="1524000" cy="12700"/>
           </a:xfrm>
           <a:prstGeom prst="rect">
@@ -3992,7 +3992,7 @@
         </p:nvSpPr>
         <p:spPr>
           <a:xfrm>
-            <a:off x="10414000" y="6477000"/>
+            <a:off x="14478000" y="8763000"/>
             <a:ext cx="1016000" cy="254000"/>
           </a:xfrm>
           <a:prstGeom prst="rect">
@@ -4577,7 +4577,7 @@
         </p:nvSpPr>
         <p:spPr>
           <a:xfrm>
-            <a:off x="8890000" y="254000"/>
+            <a:off x="12954000" y="254000"/>
             <a:ext cx="2540000" cy="304800"/>
           </a:xfrm>
           <a:prstGeom prst="rect">
@@ -4613,7 +4613,7 @@
         <p:spPr>
           <a:xfrm>
             <a:off x="0" y="635000"/>
-            <a:ext cx="50800" cy="5588000"/>
+            <a:ext cx="50800" cy="7874000"/>
           </a:xfrm>
           <a:prstGeom prst="rect">
             <a:avLst/>
@@ -4656,7 +4656,7 @@
         </p:nvSpPr>
         <p:spPr>
           <a:xfrm>
-            <a:off x="762000" y="6413500"/>
+            <a:off x="762000" y="8699500"/>
             <a:ext cx="1524000" cy="12700"/>
           </a:xfrm>
           <a:prstGeom prst="rect">
@@ -4700,7 +4700,7 @@
         </p:nvSpPr>
         <p:spPr>
           <a:xfrm>
-            <a:off x="10414000" y="6477000"/>
+            <a:off x="14478000" y="8763000"/>
             <a:ext cx="1016000" cy="254000"/>
           </a:xfrm>
           <a:prstGeom prst="rect">
@@ -5705,7 +5705,7 @@
         </p:nvSpPr>
         <p:spPr>
           <a:xfrm>
-            <a:off x="8890000" y="254000"/>
+            <a:off x="12954000" y="254000"/>
             <a:ext cx="2540000" cy="304800"/>
           </a:xfrm>
           <a:prstGeom prst="rect">
@@ -5741,7 +5741,7 @@
         <p:spPr>
           <a:xfrm>
             <a:off x="0" y="635000"/>
-            <a:ext cx="50800" cy="5588000"/>
+            <a:ext cx="50800" cy="7874000"/>
           </a:xfrm>
           <a:prstGeom prst="rect">
             <a:avLst/>
@@ -5784,7 +5784,7 @@
         </p:nvSpPr>
         <p:spPr>
           <a:xfrm>
-            <a:off x="762000" y="6413500"/>
+            <a:off x="762000" y="8699500"/>
             <a:ext cx="1524000" cy="12700"/>
           </a:xfrm>
           <a:prstGeom prst="rect">
@@ -5828,7 +5828,7 @@
         </p:nvSpPr>
         <p:spPr>
           <a:xfrm>
-            <a:off x="10414000" y="6477000"/>
+            <a:off x="14478000" y="8763000"/>
             <a:ext cx="1016000" cy="254000"/>
           </a:xfrm>
           <a:prstGeom prst="rect">
@@ -7643,7 +7643,7 @@
         </p:nvSpPr>
         <p:spPr>
           <a:xfrm>
-            <a:off x="8890000" y="254000"/>
+            <a:off x="12954000" y="254000"/>
             <a:ext cx="2540000" cy="304800"/>
           </a:xfrm>
           <a:prstGeom prst="rect">
@@ -7679,7 +7679,7 @@
         <p:spPr>
           <a:xfrm>
             <a:off x="0" y="635000"/>
-            <a:ext cx="50800" cy="5588000"/>
+            <a:ext cx="50800" cy="7874000"/>
           </a:xfrm>
           <a:prstGeom prst="rect">
             <a:avLst/>
@@ -7722,7 +7722,7 @@
         </p:nvSpPr>
         <p:spPr>
           <a:xfrm>
-            <a:off x="762000" y="6413500"/>
+            <a:off x="762000" y="8699500"/>
             <a:ext cx="1524000" cy="12700"/>
           </a:xfrm>
           <a:prstGeom prst="rect">
@@ -7766,7 +7766,7 @@
         </p:nvSpPr>
         <p:spPr>
           <a:xfrm>
-            <a:off x="10414000" y="6477000"/>
+            <a:off x="14478000" y="8763000"/>
             <a:ext cx="1016000" cy="254000"/>
           </a:xfrm>
           <a:prstGeom prst="rect">
@@ -11818,7 +11818,7 @@
         </p:nvSpPr>
         <p:spPr>
           <a:xfrm>
-            <a:off x="8890000" y="254000"/>
+            <a:off x="12954000" y="254000"/>
             <a:ext cx="2540000" cy="304800"/>
           </a:xfrm>
           <a:prstGeom prst="rect">
@@ -11854,7 +11854,7 @@
         <p:spPr>
           <a:xfrm>
             <a:off x="0" y="635000"/>
-            <a:ext cx="50800" cy="5588000"/>
+            <a:ext cx="50800" cy="7874000"/>
           </a:xfrm>
           <a:prstGeom prst="rect">
             <a:avLst/>
@@ -11897,7 +11897,7 @@
         </p:nvSpPr>
         <p:spPr>
           <a:xfrm>
-            <a:off x="762000" y="6413500"/>
+            <a:off x="762000" y="8699500"/>
             <a:ext cx="1524000" cy="12700"/>
           </a:xfrm>
           <a:prstGeom prst="rect">
@@ -11941,7 +11941,7 @@
         </p:nvSpPr>
         <p:spPr>
           <a:xfrm>
-            <a:off x="10414000" y="6477000"/>
+            <a:off x="14478000" y="8763000"/>
             <a:ext cx="1016000" cy="254000"/>
           </a:xfrm>
           <a:prstGeom prst="rect">
@@ -15800,7 +15800,7 @@
         </p:nvSpPr>
         <p:spPr>
           <a:xfrm>
-            <a:off x="8890000" y="254000"/>
+            <a:off x="12954000" y="254000"/>
             <a:ext cx="2540000" cy="304800"/>
           </a:xfrm>
           <a:prstGeom prst="rect">
@@ -15836,7 +15836,7 @@
         <p:spPr>
           <a:xfrm>
             <a:off x="0" y="635000"/>
-            <a:ext cx="50800" cy="5588000"/>
+            <a:ext cx="50800" cy="7874000"/>
           </a:xfrm>
           <a:prstGeom prst="rect">
             <a:avLst/>
@@ -15879,7 +15879,7 @@
         </p:nvSpPr>
         <p:spPr>
           <a:xfrm>
-            <a:off x="762000" y="6413500"/>
+            <a:off x="762000" y="8699500"/>
             <a:ext cx="1524000" cy="12700"/>
           </a:xfrm>
           <a:prstGeom prst="rect">
@@ -15923,7 +15923,7 @@
         </p:nvSpPr>
         <p:spPr>
           <a:xfrm>
-            <a:off x="10414000" y="6477000"/>
+            <a:off x="14478000" y="8763000"/>
             <a:ext cx="1016000" cy="254000"/>
           </a:xfrm>
           <a:prstGeom prst="rect">
@@ -18548,7 +18548,7 @@
         </p:nvSpPr>
         <p:spPr>
           <a:xfrm>
-            <a:off x="8890000" y="254000"/>
+            <a:off x="12954000" y="254000"/>
             <a:ext cx="2540000" cy="304800"/>
           </a:xfrm>
           <a:prstGeom prst="rect">
@@ -18584,7 +18584,7 @@
         <p:spPr>
           <a:xfrm>
             <a:off x="0" y="635000"/>
-            <a:ext cx="50800" cy="5588000"/>
+            <a:ext cx="50800" cy="7874000"/>
           </a:xfrm>
           <a:prstGeom prst="rect">
             <a:avLst/>
@@ -18627,7 +18627,7 @@
         </p:nvSpPr>
         <p:spPr>
           <a:xfrm>
-            <a:off x="762000" y="6413500"/>
+            <a:off x="762000" y="8699500"/>
             <a:ext cx="1524000" cy="12700"/>
           </a:xfrm>
           <a:prstGeom prst="rect">
@@ -18671,7 +18671,7 @@
         </p:nvSpPr>
         <p:spPr>
           <a:xfrm>
-            <a:off x="10414000" y="6477000"/>
+            <a:off x="14478000" y="8763000"/>
             <a:ext cx="1016000" cy="254000"/>
           </a:xfrm>
           <a:prstGeom prst="rect">
@@ -18707,7 +18707,7 @@
         <p:spPr>
           <a:xfrm>
             <a:off x="762000" y="889000"/>
-            <a:ext cx="10668000" cy="635000"/>
+            <a:ext cx="14732000" cy="635000"/>
           </a:xfrm>
           <a:prstGeom prst="rect">
             <a:avLst/>
@@ -18742,7 +18742,7 @@
         <p:spPr>
           <a:xfrm>
             <a:off x="762000" y="1498600"/>
-            <a:ext cx="10668000" cy="381000"/>
+            <a:ext cx="14732000" cy="381000"/>
           </a:xfrm>
           <a:prstGeom prst="rect">
             <a:avLst/>
@@ -20335,7 +20335,7 @@
         </p:nvSpPr>
         <p:spPr>
           <a:xfrm>
-            <a:off x="8890000" y="254000"/>
+            <a:off x="12954000" y="254000"/>
             <a:ext cx="2540000" cy="304800"/>
           </a:xfrm>
           <a:prstGeom prst="rect">
@@ -20371,7 +20371,7 @@
         <p:spPr>
           <a:xfrm>
             <a:off x="0" y="635000"/>
-            <a:ext cx="50800" cy="5588000"/>
+            <a:ext cx="50800" cy="7874000"/>
           </a:xfrm>
           <a:prstGeom prst="rect">
             <a:avLst/>
@@ -20414,7 +20414,7 @@
         </p:nvSpPr>
         <p:spPr>
           <a:xfrm>
-            <a:off x="762000" y="6413500"/>
+            <a:off x="762000" y="8699500"/>
             <a:ext cx="1524000" cy="12700"/>
           </a:xfrm>
           <a:prstGeom prst="rect">
@@ -20458,7 +20458,7 @@
         </p:nvSpPr>
         <p:spPr>
           <a:xfrm>
-            <a:off x="10414000" y="6477000"/>
+            <a:off x="14478000" y="8763000"/>
             <a:ext cx="1016000" cy="254000"/>
           </a:xfrm>
           <a:prstGeom prst="rect">
@@ -20494,7 +20494,7 @@
         <p:spPr>
           <a:xfrm>
             <a:off x="762000" y="889000"/>
-            <a:ext cx="10668000" cy="635000"/>
+            <a:ext cx="14732000" cy="635000"/>
           </a:xfrm>
           <a:prstGeom prst="rect">
             <a:avLst/>
@@ -20529,7 +20529,7 @@
         <p:spPr>
           <a:xfrm>
             <a:off x="762000" y="1498600"/>
-            <a:ext cx="10668000" cy="381000"/>
+            <a:ext cx="14732000" cy="381000"/>
           </a:xfrm>
           <a:prstGeom prst="rect">
             <a:avLst/>
@@ -21919,7 +21919,7 @@
         </p:nvSpPr>
         <p:spPr>
           <a:xfrm>
-            <a:off x="8890000" y="254000"/>
+            <a:off x="12954000" y="254000"/>
             <a:ext cx="2540000" cy="304800"/>
           </a:xfrm>
           <a:prstGeom prst="rect">
@@ -21955,7 +21955,7 @@
         <p:spPr>
           <a:xfrm>
             <a:off x="0" y="635000"/>
-            <a:ext cx="50800" cy="5588000"/>
+            <a:ext cx="50800" cy="7874000"/>
           </a:xfrm>
           <a:prstGeom prst="rect">
             <a:avLst/>
@@ -21998,7 +21998,7 @@
         </p:nvSpPr>
         <p:spPr>
           <a:xfrm>
-            <a:off x="762000" y="6413500"/>
+            <a:off x="762000" y="8699500"/>
             <a:ext cx="1524000" cy="12700"/>
           </a:xfrm>
           <a:prstGeom prst="rect">
@@ -22042,7 +22042,7 @@
         </p:nvSpPr>
         <p:spPr>
           <a:xfrm>
-            <a:off x="10414000" y="6477000"/>
+            <a:off x="14478000" y="8763000"/>
             <a:ext cx="1016000" cy="254000"/>
           </a:xfrm>
           <a:prstGeom prst="rect">
@@ -22078,7 +22078,7 @@
         <p:spPr>
           <a:xfrm>
             <a:off x="762000" y="889000"/>
-            <a:ext cx="10668000" cy="635000"/>
+            <a:ext cx="14732000" cy="635000"/>
           </a:xfrm>
           <a:prstGeom prst="rect">
             <a:avLst/>
@@ -22113,7 +22113,7 @@
         <p:spPr>
           <a:xfrm>
             <a:off x="762000" y="1498600"/>
-            <a:ext cx="10668000" cy="381000"/>
+            <a:ext cx="14732000" cy="381000"/>
           </a:xfrm>
           <a:prstGeom prst="rect">
             <a:avLst/>
@@ -23600,7 +23600,7 @@
         </p:nvSpPr>
         <p:spPr>
           <a:xfrm>
-            <a:off x="8890000" y="254000"/>
+            <a:off x="12954000" y="254000"/>
             <a:ext cx="2540000" cy="304800"/>
           </a:xfrm>
           <a:prstGeom prst="rect">
@@ -23636,7 +23636,7 @@
         <p:spPr>
           <a:xfrm>
             <a:off x="0" y="635000"/>
-            <a:ext cx="50800" cy="5588000"/>
+            <a:ext cx="50800" cy="7874000"/>
           </a:xfrm>
           <a:prstGeom prst="rect">
             <a:avLst/>
@@ -23679,7 +23679,7 @@
         </p:nvSpPr>
         <p:spPr>
           <a:xfrm>
-            <a:off x="762000" y="6413500"/>
+            <a:off x="762000" y="8699500"/>
             <a:ext cx="1524000" cy="12700"/>
           </a:xfrm>
           <a:prstGeom prst="rect">
@@ -23723,7 +23723,7 @@
         </p:nvSpPr>
         <p:spPr>
           <a:xfrm>
-            <a:off x="10414000" y="6477000"/>
+            <a:off x="14478000" y="8763000"/>
             <a:ext cx="1016000" cy="254000"/>
           </a:xfrm>
           <a:prstGeom prst="rect">
@@ -23759,7 +23759,7 @@
         <p:spPr>
           <a:xfrm>
             <a:off x="0" y="0"/>
-            <a:ext cx="12192000" cy="6858000"/>
+            <a:ext cx="16256000" cy="9144000"/>
           </a:xfrm>
           <a:prstGeom prst="rect">
             <a:avLst/>
@@ -23803,7 +23803,7 @@
         <p:spPr>
           <a:xfrm>
             <a:off x="0" y="635000"/>
-            <a:ext cx="50800" cy="5588000"/>
+            <a:ext cx="50800" cy="7874000"/>
           </a:xfrm>
           <a:prstGeom prst="rect">
             <a:avLst/>
@@ -23847,7 +23847,7 @@
         <p:spPr>
           <a:xfrm>
             <a:off x="0" y="2286000"/>
-            <a:ext cx="12192000" cy="2032000"/>
+            <a:ext cx="16256000" cy="2032000"/>
           </a:xfrm>
           <a:prstGeom prst="rect">
             <a:avLst/>
@@ -23882,7 +23882,7 @@
         <p:spPr>
           <a:xfrm>
             <a:off x="0" y="4572000"/>
-            <a:ext cx="12192000" cy="508000"/>
+            <a:ext cx="16256000" cy="508000"/>
           </a:xfrm>
           <a:prstGeom prst="rect">
             <a:avLst/>
@@ -23961,7 +23961,7 @@
         <p:spPr>
           <a:xfrm>
             <a:off x="0" y="5842000"/>
-            <a:ext cx="12192000" cy="355600"/>
+            <a:ext cx="16256000" cy="355600"/>
           </a:xfrm>
           <a:prstGeom prst="rect">
             <a:avLst/>
@@ -23996,7 +23996,7 @@
         <p:spPr>
           <a:xfrm>
             <a:off x="0" y="6223000"/>
-            <a:ext cx="12192000" cy="355600"/>
+            <a:ext cx="16256000" cy="355600"/>
           </a:xfrm>
           <a:prstGeom prst="rect">
             <a:avLst/>
@@ -24031,7 +24031,7 @@
         <p:spPr>
           <a:xfrm>
             <a:off x="0" y="6604000"/>
-            <a:ext cx="12192000" cy="355600"/>
+            <a:ext cx="16256000" cy="355600"/>
           </a:xfrm>
           <a:prstGeom prst="rect">
             <a:avLst/>
@@ -24066,7 +24066,7 @@
         <p:spPr>
           <a:xfrm>
             <a:off x="0" y="7874000"/>
-            <a:ext cx="12192000" cy="508000"/>
+            <a:ext cx="16256000" cy="508000"/>
           </a:xfrm>
           <a:prstGeom prst="rect">
             <a:avLst/>
@@ -24101,7 +24101,7 @@
         <p:spPr>
           <a:xfrm>
             <a:off x="0" y="8636000"/>
-            <a:ext cx="12192000" cy="254000"/>
+            <a:ext cx="16256000" cy="254000"/>
           </a:xfrm>
           <a:prstGeom prst="rect">
             <a:avLst/>
@@ -24188,7 +24188,7 @@
         </p:nvSpPr>
         <p:spPr>
           <a:xfrm>
-            <a:off x="8890000" y="254000"/>
+            <a:off x="12954000" y="254000"/>
             <a:ext cx="2540000" cy="304800"/>
           </a:xfrm>
           <a:prstGeom prst="rect">
@@ -24224,7 +24224,7 @@
         <p:spPr>
           <a:xfrm>
             <a:off x="0" y="635000"/>
-            <a:ext cx="50800" cy="5588000"/>
+            <a:ext cx="50800" cy="7874000"/>
           </a:xfrm>
           <a:prstGeom prst="rect">
             <a:avLst/>
@@ -24267,7 +24267,7 @@
         </p:nvSpPr>
         <p:spPr>
           <a:xfrm>
-            <a:off x="762000" y="6413500"/>
+            <a:off x="762000" y="8699500"/>
             <a:ext cx="1524000" cy="12700"/>
           </a:xfrm>
           <a:prstGeom prst="rect">
@@ -24311,7 +24311,7 @@
         </p:nvSpPr>
         <p:spPr>
           <a:xfrm>
-            <a:off x="10414000" y="6477000"/>
+            <a:off x="14478000" y="8763000"/>
             <a:ext cx="1016000" cy="254000"/>
           </a:xfrm>
           <a:prstGeom prst="rect">
@@ -24347,7 +24347,7 @@
         <p:spPr>
           <a:xfrm>
             <a:off x="762000" y="889000"/>
-            <a:ext cx="10668000" cy="635000"/>
+            <a:ext cx="14732000" cy="635000"/>
           </a:xfrm>
           <a:prstGeom prst="rect">
             <a:avLst/>
@@ -24382,7 +24382,7 @@
         <p:spPr>
           <a:xfrm>
             <a:off x="762000" y="1498600"/>
-            <a:ext cx="10668000" cy="381000"/>
+            <a:ext cx="14732000" cy="381000"/>
           </a:xfrm>
           <a:prstGeom prst="rect">
             <a:avLst/>
@@ -25389,7 +25389,7 @@
         </p:nvSpPr>
         <p:spPr>
           <a:xfrm>
-            <a:off x="8890000" y="254000"/>
+            <a:off x="12954000" y="254000"/>
             <a:ext cx="2540000" cy="304800"/>
           </a:xfrm>
           <a:prstGeom prst="rect">
@@ -25425,7 +25425,7 @@
         <p:spPr>
           <a:xfrm>
             <a:off x="0" y="635000"/>
-            <a:ext cx="50800" cy="5588000"/>
+            <a:ext cx="50800" cy="7874000"/>
           </a:xfrm>
           <a:prstGeom prst="rect">
             <a:avLst/>
@@ -25468,7 +25468,7 @@
         </p:nvSpPr>
         <p:spPr>
           <a:xfrm>
-            <a:off x="762000" y="6413500"/>
+            <a:off x="762000" y="8699500"/>
             <a:ext cx="1524000" cy="12700"/>
           </a:xfrm>
           <a:prstGeom prst="rect">
@@ -25512,7 +25512,7 @@
         </p:nvSpPr>
         <p:spPr>
           <a:xfrm>
-            <a:off x="10414000" y="6477000"/>
+            <a:off x="14478000" y="8763000"/>
             <a:ext cx="1016000" cy="254000"/>
           </a:xfrm>
           <a:prstGeom prst="rect">
@@ -25548,7 +25548,7 @@
         <p:spPr>
           <a:xfrm>
             <a:off x="762000" y="889000"/>
-            <a:ext cx="10668000" cy="635000"/>
+            <a:ext cx="14732000" cy="635000"/>
           </a:xfrm>
           <a:prstGeom prst="rect">
             <a:avLst/>
@@ -25583,7 +25583,7 @@
         <p:spPr>
           <a:xfrm>
             <a:off x="762000" y="1498600"/>
-            <a:ext cx="10668000" cy="381000"/>
+            <a:ext cx="14732000" cy="381000"/>
           </a:xfrm>
           <a:prstGeom prst="rect">
             <a:avLst/>
@@ -26927,7 +26927,7 @@
         </p:nvSpPr>
         <p:spPr>
           <a:xfrm>
-            <a:off x="8890000" y="254000"/>
+            <a:off x="12954000" y="254000"/>
             <a:ext cx="2540000" cy="304800"/>
           </a:xfrm>
           <a:prstGeom prst="rect">
@@ -26963,7 +26963,7 @@
         <p:spPr>
           <a:xfrm>
             <a:off x="0" y="635000"/>
-            <a:ext cx="50800" cy="5588000"/>
+            <a:ext cx="50800" cy="7874000"/>
           </a:xfrm>
           <a:prstGeom prst="rect">
             <a:avLst/>
@@ -27006,7 +27006,7 @@
         </p:nvSpPr>
         <p:spPr>
           <a:xfrm>
-            <a:off x="762000" y="6413500"/>
+            <a:off x="762000" y="8699500"/>
             <a:ext cx="1524000" cy="12700"/>
           </a:xfrm>
           <a:prstGeom prst="rect">
@@ -27050,7 +27050,7 @@
         </p:nvSpPr>
         <p:spPr>
           <a:xfrm>
-            <a:off x="10414000" y="6477000"/>
+            <a:off x="14478000" y="8763000"/>
             <a:ext cx="1016000" cy="254000"/>
           </a:xfrm>
           <a:prstGeom prst="rect">
@@ -27086,7 +27086,7 @@
         <p:spPr>
           <a:xfrm>
             <a:off x="762000" y="889000"/>
-            <a:ext cx="10668000" cy="635000"/>
+            <a:ext cx="14732000" cy="635000"/>
           </a:xfrm>
           <a:prstGeom prst="rect">
             <a:avLst/>
@@ -27121,7 +27121,7 @@
         <p:spPr>
           <a:xfrm>
             <a:off x="762000" y="1498600"/>
-            <a:ext cx="10668000" cy="381000"/>
+            <a:ext cx="14732000" cy="381000"/>
           </a:xfrm>
           <a:prstGeom prst="rect">
             <a:avLst/>
@@ -30123,7 +30123,7 @@
         </p:nvSpPr>
         <p:spPr>
           <a:xfrm>
-            <a:off x="8890000" y="254000"/>
+            <a:off x="12954000" y="254000"/>
             <a:ext cx="2540000" cy="304800"/>
           </a:xfrm>
           <a:prstGeom prst="rect">
@@ -30159,7 +30159,7 @@
         <p:spPr>
           <a:xfrm>
             <a:off x="0" y="635000"/>
-            <a:ext cx="50800" cy="5588000"/>
+            <a:ext cx="50800" cy="7874000"/>
           </a:xfrm>
           <a:prstGeom prst="rect">
             <a:avLst/>
@@ -30202,7 +30202,7 @@
         </p:nvSpPr>
         <p:spPr>
           <a:xfrm>
-            <a:off x="762000" y="6413500"/>
+            <a:off x="762000" y="8699500"/>
             <a:ext cx="1524000" cy="12700"/>
           </a:xfrm>
           <a:prstGeom prst="rect">
@@ -30246,7 +30246,7 @@
         </p:nvSpPr>
         <p:spPr>
           <a:xfrm>
-            <a:off x="10414000" y="6477000"/>
+            <a:off x="14478000" y="8763000"/>
             <a:ext cx="1016000" cy="254000"/>
           </a:xfrm>
           <a:prstGeom prst="rect">
@@ -30282,7 +30282,7 @@
         <p:spPr>
           <a:xfrm>
             <a:off x="762000" y="889000"/>
-            <a:ext cx="10668000" cy="635000"/>
+            <a:ext cx="14732000" cy="635000"/>
           </a:xfrm>
           <a:prstGeom prst="rect">
             <a:avLst/>
@@ -30317,7 +30317,7 @@
         <p:spPr>
           <a:xfrm>
             <a:off x="762000" y="1498600"/>
-            <a:ext cx="10668000" cy="381000"/>
+            <a:ext cx="14732000" cy="381000"/>
           </a:xfrm>
           <a:prstGeom prst="rect">
             <a:avLst/>
@@ -32176,7 +32176,7 @@
         </p:nvSpPr>
         <p:spPr>
           <a:xfrm>
-            <a:off x="8890000" y="254000"/>
+            <a:off x="12954000" y="254000"/>
             <a:ext cx="2540000" cy="304800"/>
           </a:xfrm>
           <a:prstGeom prst="rect">
@@ -32212,7 +32212,7 @@
         <p:spPr>
           <a:xfrm>
             <a:off x="0" y="635000"/>
-            <a:ext cx="50800" cy="5588000"/>
+            <a:ext cx="50800" cy="7874000"/>
           </a:xfrm>
           <a:prstGeom prst="rect">
             <a:avLst/>
@@ -32255,7 +32255,7 @@
         </p:nvSpPr>
         <p:spPr>
           <a:xfrm>
-            <a:off x="762000" y="6413500"/>
+            <a:off x="762000" y="8699500"/>
             <a:ext cx="1524000" cy="12700"/>
           </a:xfrm>
           <a:prstGeom prst="rect">
@@ -32299,7 +32299,7 @@
         </p:nvSpPr>
         <p:spPr>
           <a:xfrm>
-            <a:off x="10414000" y="6477000"/>
+            <a:off x="14478000" y="8763000"/>
             <a:ext cx="1016000" cy="254000"/>
           </a:xfrm>
           <a:prstGeom prst="rect">
@@ -32335,7 +32335,7 @@
         <p:spPr>
           <a:xfrm>
             <a:off x="762000" y="889000"/>
-            <a:ext cx="10668000" cy="635000"/>
+            <a:ext cx="14732000" cy="635000"/>
           </a:xfrm>
           <a:prstGeom prst="rect">
             <a:avLst/>
@@ -32370,7 +32370,7 @@
         <p:spPr>
           <a:xfrm>
             <a:off x="762000" y="1498600"/>
-            <a:ext cx="10668000" cy="381000"/>
+            <a:ext cx="14732000" cy="381000"/>
           </a:xfrm>
           <a:prstGeom prst="rect">
             <a:avLst/>
@@ -33471,7 +33471,7 @@
         </p:nvSpPr>
         <p:spPr>
           <a:xfrm>
-            <a:off x="8890000" y="254000"/>
+            <a:off x="12954000" y="254000"/>
             <a:ext cx="2540000" cy="304800"/>
           </a:xfrm>
           <a:prstGeom prst="rect">
@@ -33507,7 +33507,7 @@
         <p:spPr>
           <a:xfrm>
             <a:off x="0" y="635000"/>
-            <a:ext cx="50800" cy="5588000"/>
+            <a:ext cx="50800" cy="7874000"/>
           </a:xfrm>
           <a:prstGeom prst="rect">
             <a:avLst/>
@@ -33550,7 +33550,7 @@
         </p:nvSpPr>
         <p:spPr>
           <a:xfrm>
-            <a:off x="762000" y="6413500"/>
+            <a:off x="762000" y="8699500"/>
             <a:ext cx="1524000" cy="12700"/>
           </a:xfrm>
           <a:prstGeom prst="rect">
@@ -33594,7 +33594,7 @@
         </p:nvSpPr>
         <p:spPr>
           <a:xfrm>
-            <a:off x="10414000" y="6477000"/>
+            <a:off x="14478000" y="8763000"/>
             <a:ext cx="1016000" cy="254000"/>
           </a:xfrm>
           <a:prstGeom prst="rect">
@@ -33630,7 +33630,7 @@
         <p:spPr>
           <a:xfrm>
             <a:off x="762000" y="889000"/>
-            <a:ext cx="10668000" cy="635000"/>
+            <a:ext cx="14732000" cy="635000"/>
           </a:xfrm>
           <a:prstGeom prst="rect">
             <a:avLst/>
@@ -33665,7 +33665,7 @@
         <p:spPr>
           <a:xfrm>
             <a:off x="762000" y="1498600"/>
-            <a:ext cx="10668000" cy="381000"/>
+            <a:ext cx="14732000" cy="381000"/>
           </a:xfrm>
           <a:prstGeom prst="rect">
             <a:avLst/>
@@ -35765,7 +35765,7 @@
         </p:nvSpPr>
         <p:spPr>
           <a:xfrm>
-            <a:off x="8890000" y="254000"/>
+            <a:off x="12954000" y="254000"/>
             <a:ext cx="2540000" cy="304800"/>
           </a:xfrm>
           <a:prstGeom prst="rect">
@@ -35801,7 +35801,7 @@
         <p:spPr>
           <a:xfrm>
             <a:off x="0" y="635000"/>
-            <a:ext cx="50800" cy="5588000"/>
+            <a:ext cx="50800" cy="7874000"/>
           </a:xfrm>
           <a:prstGeom prst="rect">
             <a:avLst/>
@@ -35844,7 +35844,7 @@
         </p:nvSpPr>
         <p:spPr>
           <a:xfrm>
-            <a:off x="762000" y="6413500"/>
+            <a:off x="762000" y="8699500"/>
             <a:ext cx="1524000" cy="12700"/>
           </a:xfrm>
           <a:prstGeom prst="rect">
@@ -35888,7 +35888,7 @@
         </p:nvSpPr>
         <p:spPr>
           <a:xfrm>
-            <a:off x="10414000" y="6477000"/>
+            <a:off x="14478000" y="8763000"/>
             <a:ext cx="1016000" cy="254000"/>
           </a:xfrm>
           <a:prstGeom prst="rect">
@@ -36910,7 +36910,7 @@
         </p:nvSpPr>
         <p:spPr>
           <a:xfrm>
-            <a:off x="8890000" y="254000"/>
+            <a:off x="12954000" y="254000"/>
             <a:ext cx="2540000" cy="304800"/>
           </a:xfrm>
           <a:prstGeom prst="rect">
@@ -36946,7 +36946,7 @@
         <p:spPr>
           <a:xfrm>
             <a:off x="0" y="635000"/>
-            <a:ext cx="50800" cy="5588000"/>
+            <a:ext cx="50800" cy="7874000"/>
           </a:xfrm>
           <a:prstGeom prst="rect">
             <a:avLst/>
@@ -36989,7 +36989,7 @@
         </p:nvSpPr>
         <p:spPr>
           <a:xfrm>
-            <a:off x="762000" y="6413500"/>
+            <a:off x="762000" y="8699500"/>
             <a:ext cx="1524000" cy="12700"/>
           </a:xfrm>
           <a:prstGeom prst="rect">
@@ -37033,7 +37033,7 @@
         </p:nvSpPr>
         <p:spPr>
           <a:xfrm>
-            <a:off x="10414000" y="6477000"/>
+            <a:off x="14478000" y="8763000"/>
             <a:ext cx="1016000" cy="254000"/>
           </a:xfrm>
           <a:prstGeom prst="rect">

</xml_diff>

<commit_message>
fix(ppt): catch remaining literal color references in tuple 3rd-element pattern
The Task 14 sed only matched color='...' keyword args. Tuple 3rd-element
patterns like ('name', 'desc', '#FA8C16') slipped through. Apply extended
sed to catch all positional patterns, including multi-space separators.

Also catch:
- fill='#FA8C16' / border='#722ED1' keyword args
- 4-elem tuples like (Pt(320), 'name', '#FA8C16', 'desc')
- accent_color='#13C2C2' in add_page_title calls
- '#1890FF' (Ant Design blue) in s05

Result: all 21 slides regenerated, 0 unexpected text colors.
</commit_message>
<xml_diff>
--- a/ppt/output/学习智能体系统_汇报PPT.pptx
+++ b/ppt/output/学习智能体系统_汇报PPT.pptx
@@ -13484,7 +13484,7 @@
           </a:solidFill>
           <a:ln w="12700">
             <a:solidFill>
-              <a:srgbClr val="722ED1"/>
+              <a:srgbClr val="C00000"/>
             </a:solidFill>
           </a:ln>
           <a:effectLst/>
@@ -13526,7 +13526,7 @@
             <a:avLst/>
           </a:prstGeom>
           <a:solidFill>
-            <a:srgbClr val="722ED1"/>
+            <a:srgbClr val="C00000"/>
           </a:solidFill>
           <a:ln>
             <a:noFill/>
@@ -13868,7 +13868,7 @@
           </a:solidFill>
           <a:ln w="12700">
             <a:solidFill>
-              <a:srgbClr val="722ED1"/>
+              <a:srgbClr val="C00000"/>
             </a:solidFill>
           </a:ln>
           <a:effectLst/>
@@ -13910,7 +13910,7 @@
             <a:avLst/>
           </a:prstGeom>
           <a:solidFill>
-            <a:srgbClr val="722ED1"/>
+            <a:srgbClr val="C00000"/>
           </a:solidFill>
           <a:ln>
             <a:noFill/>
@@ -14711,7 +14711,7 @@
           </a:solidFill>
           <a:ln w="19050">
             <a:solidFill>
-              <a:srgbClr val="722ED1"/>
+              <a:srgbClr val="C00000"/>
             </a:solidFill>
           </a:ln>
           <a:effectLst/>
@@ -14753,7 +14753,7 @@
             <a:avLst/>
           </a:prstGeom>
           <a:solidFill>
-            <a:srgbClr val="722ED1"/>
+            <a:srgbClr val="C00000"/>
           </a:solidFill>
           <a:ln>
             <a:noFill/>
@@ -14808,7 +14808,7 @@
             <a:r>
               <a:rPr sz="1500" b="1">
                 <a:solidFill>
-                  <a:srgbClr val="722ED1"/>
+                  <a:srgbClr val="C00000"/>
                 </a:solidFill>
                 <a:latin typeface="OPPO Sans"/>
                 <a:ea typeface="OPPO Sans"/>
@@ -15362,7 +15362,7 @@
             </a:avLst>
           </a:prstGeom>
           <a:solidFill>
-            <a:srgbClr val="FA8C16"/>
+            <a:srgbClr val="D3A518"/>
           </a:solidFill>
           <a:ln>
             <a:noFill/>
@@ -15544,7 +15544,7 @@
             </a:avLst>
           </a:prstGeom>
           <a:solidFill>
-            <a:srgbClr val="722ED1"/>
+            <a:srgbClr val="C00000"/>
           </a:solidFill>
           <a:ln>
             <a:noFill/>
@@ -16232,7 +16232,7 @@
           </a:solidFill>
           <a:ln w="12700">
             <a:solidFill>
-              <a:srgbClr val="FA8C16"/>
+              <a:srgbClr val="D3A518"/>
             </a:solidFill>
           </a:ln>
           <a:effectLst/>
@@ -16274,7 +16274,7 @@
             <a:avLst/>
           </a:prstGeom>
           <a:solidFill>
-            <a:srgbClr val="FA8C16"/>
+            <a:srgbClr val="D3A518"/>
           </a:solidFill>
           <a:ln>
             <a:noFill/>
@@ -16329,7 +16329,7 @@
             <a:r>
               <a:rPr sz="1500" b="1">
                 <a:solidFill>
-                  <a:srgbClr val="FA8C16"/>
+                  <a:srgbClr val="D3A518"/>
                 </a:solidFill>
                 <a:latin typeface="OPPO Sans"/>
                 <a:ea typeface="OPPO Sans"/>
@@ -16396,7 +16396,7 @@
           </a:solidFill>
           <a:ln w="12700">
             <a:solidFill>
-              <a:srgbClr val="722ED1"/>
+              <a:srgbClr val="C00000"/>
             </a:solidFill>
           </a:ln>
           <a:effectLst/>
@@ -16438,7 +16438,7 @@
             <a:avLst/>
           </a:prstGeom>
           <a:solidFill>
-            <a:srgbClr val="722ED1"/>
+            <a:srgbClr val="C00000"/>
           </a:solidFill>
           <a:ln>
             <a:noFill/>
@@ -16493,7 +16493,7 @@
             <a:r>
               <a:rPr sz="1500" b="1">
                 <a:solidFill>
-                  <a:srgbClr val="722ED1"/>
+                  <a:srgbClr val="C00000"/>
                 </a:solidFill>
                 <a:latin typeface="OPPO Sans"/>
                 <a:ea typeface="OPPO Sans"/>
@@ -16801,7 +16801,7 @@
             <a:avLst/>
           </a:prstGeom>
           <a:solidFill>
-            <a:srgbClr val="13C2C2"/>
+            <a:srgbClr val="002060"/>
           </a:solidFill>
           <a:ln>
             <a:noFill/>
@@ -19995,7 +19995,7 @@
             <a:avLst/>
           </a:prstGeom>
           <a:solidFill>
-            <a:srgbClr val="13C2C2"/>
+            <a:srgbClr val="002060"/>
           </a:solidFill>
           <a:ln>
             <a:noFill/>
@@ -21168,7 +21168,7 @@
             <a:r>
               <a:rPr sz="1700" b="1">
                 <a:solidFill>
-                  <a:srgbClr val="FA8C16"/>
+                  <a:srgbClr val="2D4470"/>
                 </a:solidFill>
                 <a:latin typeface="OPPO Sans"/>
                 <a:ea typeface="OPPO Sans"/>
@@ -23849,7 +23849,7 @@
             </a:avLst>
           </a:prstGeom>
           <a:solidFill>
-            <a:srgbClr val="722ED1"/>
+            <a:srgbClr val="C00000"/>
           </a:solidFill>
           <a:ln>
             <a:noFill/>
@@ -24001,7 +24001,7 @@
             <a:avLst/>
           </a:prstGeom>
           <a:solidFill>
-            <a:srgbClr val="FA8C16"/>
+            <a:srgbClr val="D3A518"/>
           </a:solidFill>
           <a:ln>
             <a:noFill/>
@@ -24117,7 +24117,7 @@
             <a:avLst/>
           </a:prstGeom>
           <a:solidFill>
-            <a:srgbClr val="FA8C16"/>
+            <a:srgbClr val="D3A518"/>
           </a:solidFill>
           <a:ln>
             <a:noFill/>
@@ -24233,7 +24233,7 @@
             <a:avLst/>
           </a:prstGeom>
           <a:solidFill>
-            <a:srgbClr val="FA8C16"/>
+            <a:srgbClr val="D3A518"/>
           </a:solidFill>
           <a:ln>
             <a:noFill/>
@@ -24349,7 +24349,7 @@
             <a:avLst/>
           </a:prstGeom>
           <a:solidFill>
-            <a:srgbClr val="FA8C16"/>
+            <a:srgbClr val="D3A518"/>
           </a:solidFill>
           <a:ln>
             <a:noFill/>
@@ -24910,7 +24910,7 @@
             <a:avLst/>
           </a:prstGeom>
           <a:solidFill>
-            <a:srgbClr val="FA8C16"/>
+            <a:srgbClr val="D3A518"/>
           </a:solidFill>
           <a:ln>
             <a:noFill/>
@@ -24965,7 +24965,7 @@
             <a:r>
               <a:rPr sz="1800" b="1">
                 <a:solidFill>
-                  <a:srgbClr val="FA8C16"/>
+                  <a:srgbClr val="D3A518"/>
                 </a:solidFill>
                 <a:latin typeface="OPPO Sans"/>
                 <a:ea typeface="OPPO Sans"/>
@@ -25108,7 +25108,7 @@
             <a:avLst/>
           </a:prstGeom>
           <a:solidFill>
-            <a:srgbClr val="52C41A"/>
+            <a:srgbClr val="D3A518"/>
           </a:solidFill>
           <a:ln>
             <a:noFill/>
@@ -25163,7 +25163,7 @@
             <a:r>
               <a:rPr sz="1800" b="1">
                 <a:solidFill>
-                  <a:srgbClr val="52C41A"/>
+                  <a:srgbClr val="D3A518"/>
                 </a:solidFill>
                 <a:latin typeface="OPPO Sans"/>
                 <a:ea typeface="OPPO Sans"/>
@@ -25306,7 +25306,7 @@
             <a:avLst/>
           </a:prstGeom>
           <a:solidFill>
-            <a:srgbClr val="1890FF"/>
+            <a:srgbClr val="2D4470"/>
           </a:solidFill>
           <a:ln>
             <a:noFill/>
@@ -25361,7 +25361,7 @@
             <a:r>
               <a:rPr sz="1800" b="1">
                 <a:solidFill>
-                  <a:srgbClr val="1890FF"/>
+                  <a:srgbClr val="2D4470"/>
                 </a:solidFill>
                 <a:latin typeface="OPPO Sans"/>
                 <a:ea typeface="OPPO Sans"/>
@@ -25504,7 +25504,7 @@
             <a:avLst/>
           </a:prstGeom>
           <a:solidFill>
-            <a:srgbClr val="722ED1"/>
+            <a:srgbClr val="C00000"/>
           </a:solidFill>
           <a:ln>
             <a:noFill/>
@@ -25559,7 +25559,7 @@
             <a:r>
               <a:rPr sz="1800" b="1">
                 <a:solidFill>
-                  <a:srgbClr val="722ED1"/>
+                  <a:srgbClr val="C00000"/>
                 </a:solidFill>
                 <a:latin typeface="OPPO Sans"/>
                 <a:ea typeface="OPPO Sans"/>
@@ -25702,7 +25702,7 @@
             <a:avLst/>
           </a:prstGeom>
           <a:solidFill>
-            <a:srgbClr val="13C2C2"/>
+            <a:srgbClr val="002060"/>
           </a:solidFill>
           <a:ln>
             <a:noFill/>
@@ -25757,7 +25757,7 @@
             <a:r>
               <a:rPr sz="1800" b="1">
                 <a:solidFill>
-                  <a:srgbClr val="13C2C2"/>
+                  <a:srgbClr val="002060"/>
                 </a:solidFill>
                 <a:latin typeface="OPPO Sans"/>
                 <a:ea typeface="OPPO Sans"/>
@@ -26060,7 +26060,7 @@
           </a:solidFill>
           <a:ln w="19050">
             <a:solidFill>
-              <a:srgbClr val="FA8C16"/>
+              <a:srgbClr val="D3A518"/>
             </a:solidFill>
           </a:ln>
           <a:effectLst/>
@@ -26102,7 +26102,7 @@
             <a:avLst/>
           </a:prstGeom>
           <a:solidFill>
-            <a:srgbClr val="FA8C16"/>
+            <a:srgbClr val="D3A518"/>
           </a:solidFill>
           <a:ln>
             <a:noFill/>
@@ -26157,7 +26157,7 @@
             <a:r>
               <a:rPr sz="1800" b="1">
                 <a:solidFill>
-                  <a:srgbClr val="FA8C16"/>
+                  <a:srgbClr val="D3A518"/>
                 </a:solidFill>
                 <a:latin typeface="OPPO Sans"/>
                 <a:ea typeface="OPPO Sans"/>
@@ -26224,7 +26224,7 @@
           </a:solidFill>
           <a:ln w="19050">
             <a:solidFill>
-              <a:srgbClr val="722ED1"/>
+              <a:srgbClr val="C00000"/>
             </a:solidFill>
           </a:ln>
           <a:effectLst/>
@@ -26266,7 +26266,7 @@
             <a:avLst/>
           </a:prstGeom>
           <a:solidFill>
-            <a:srgbClr val="722ED1"/>
+            <a:srgbClr val="C00000"/>
           </a:solidFill>
           <a:ln>
             <a:noFill/>
@@ -26321,7 +26321,7 @@
             <a:r>
               <a:rPr sz="1800" b="1">
                 <a:solidFill>
-                  <a:srgbClr val="722ED1"/>
+                  <a:srgbClr val="C00000"/>
                 </a:solidFill>
                 <a:latin typeface="OPPO Sans"/>
                 <a:ea typeface="OPPO Sans"/>
@@ -26388,7 +26388,7 @@
           </a:solidFill>
           <a:ln w="19050">
             <a:solidFill>
-              <a:srgbClr val="13C2C2"/>
+              <a:srgbClr val="002060"/>
             </a:solidFill>
           </a:ln>
           <a:effectLst/>
@@ -26430,7 +26430,7 @@
             <a:avLst/>
           </a:prstGeom>
           <a:solidFill>
-            <a:srgbClr val="13C2C2"/>
+            <a:srgbClr val="002060"/>
           </a:solidFill>
           <a:ln>
             <a:noFill/>
@@ -26485,7 +26485,7 @@
             <a:r>
               <a:rPr sz="1800" b="1">
                 <a:solidFill>
-                  <a:srgbClr val="13C2C2"/>
+                  <a:srgbClr val="002060"/>
                 </a:solidFill>
                 <a:latin typeface="OPPO Sans"/>
                 <a:ea typeface="OPPO Sans"/>
@@ -27658,7 +27658,7 @@
             <a:avLst/>
           </a:prstGeom>
           <a:solidFill>
-            <a:srgbClr val="9254DE"/>
+            <a:srgbClr val="C00000"/>
           </a:solidFill>
           <a:ln>
             <a:noFill/>
@@ -27759,7 +27759,7 @@
             <a:r>
               <a:rPr sz="1800" b="1">
                 <a:solidFill>
-                  <a:srgbClr val="9254DE"/>
+                  <a:srgbClr val="C00000"/>
                 </a:solidFill>
                 <a:latin typeface="OPPO Sans"/>
                 <a:ea typeface="OPPO Sans"/>
@@ -27831,7 +27831,7 @@
             <a:r>
               <a:rPr sz="3400" b="1">
                 <a:solidFill>
-                  <a:srgbClr val="9254DE"/>
+                  <a:srgbClr val="C00000"/>
                 </a:solidFill>
                 <a:latin typeface="Weibei SC"/>
                 <a:ea typeface="Weibei SC"/>
@@ -27857,7 +27857,7 @@
           </a:prstGeom>
           <a:ln w="19050">
             <a:solidFill>
-              <a:srgbClr val="9254DE"/>
+              <a:srgbClr val="C00000"/>
             </a:solidFill>
             <a:tailEnd type="triangle" w="med" len="med"/>
           </a:ln>
@@ -27892,7 +27892,7 @@
             <a:avLst/>
           </a:prstGeom>
           <a:solidFill>
-            <a:srgbClr val="FA8C16"/>
+            <a:srgbClr val="D3A518"/>
           </a:solidFill>
           <a:ln>
             <a:noFill/>
@@ -27993,7 +27993,7 @@
             <a:r>
               <a:rPr sz="1800" b="1">
                 <a:solidFill>
-                  <a:srgbClr val="FA8C16"/>
+                  <a:srgbClr val="D3A518"/>
                 </a:solidFill>
                 <a:latin typeface="OPPO Sans"/>
                 <a:ea typeface="OPPO Sans"/>
@@ -28065,7 +28065,7 @@
             <a:r>
               <a:rPr sz="3400" b="1">
                 <a:solidFill>
-                  <a:srgbClr val="FA8C16"/>
+                  <a:srgbClr val="D3A518"/>
                 </a:solidFill>
                 <a:latin typeface="Weibei SC"/>
                 <a:ea typeface="Weibei SC"/>
@@ -28091,7 +28091,7 @@
           </a:prstGeom>
           <a:ln w="19050">
             <a:solidFill>
-              <a:srgbClr val="FA8C16"/>
+              <a:srgbClr val="D3A518"/>
             </a:solidFill>
             <a:tailEnd type="triangle" w="med" len="med"/>
           </a:ln>
@@ -29491,7 +29491,7 @@
             </a:avLst>
           </a:prstGeom>
           <a:solidFill>
-            <a:srgbClr val="FA8C16"/>
+            <a:srgbClr val="D3A518"/>
           </a:solidFill>
           <a:ln>
             <a:noFill/>
@@ -29577,7 +29577,7 @@
           </a:solidFill>
           <a:ln w="9525">
             <a:solidFill>
-              <a:srgbClr val="FA8C16"/>
+              <a:srgbClr val="D3A518"/>
             </a:solidFill>
           </a:ln>
           <a:effectLst/>
@@ -29697,7 +29697,7 @@
           </a:solidFill>
           <a:ln w="9525">
             <a:solidFill>
-              <a:srgbClr val="FA8C16"/>
+              <a:srgbClr val="D3A518"/>
             </a:solidFill>
           </a:ln>
           <a:effectLst/>
@@ -29817,7 +29817,7 @@
           </a:solidFill>
           <a:ln w="9525">
             <a:solidFill>
-              <a:srgbClr val="FA8C16"/>
+              <a:srgbClr val="D3A518"/>
             </a:solidFill>
           </a:ln>
           <a:effectLst/>
@@ -29937,7 +29937,7 @@
           </a:solidFill>
           <a:ln w="9525">
             <a:solidFill>
-              <a:srgbClr val="FA8C16"/>
+              <a:srgbClr val="D3A518"/>
             </a:solidFill>
           </a:ln>
           <a:effectLst/>
@@ -30057,7 +30057,7 @@
           </a:solidFill>
           <a:ln w="9525">
             <a:solidFill>
-              <a:srgbClr val="FA8C16"/>
+              <a:srgbClr val="D3A518"/>
             </a:solidFill>
           </a:ln>
           <a:effectLst/>
@@ -30173,7 +30173,7 @@
             </a:avLst>
           </a:prstGeom>
           <a:solidFill>
-            <a:srgbClr val="13C2C2"/>
+            <a:srgbClr val="002060"/>
           </a:solidFill>
           <a:ln>
             <a:noFill/>
@@ -30259,7 +30259,7 @@
           </a:solidFill>
           <a:ln w="9525">
             <a:solidFill>
-              <a:srgbClr val="13C2C2"/>
+              <a:srgbClr val="002060"/>
             </a:solidFill>
           </a:ln>
           <a:effectLst/>
@@ -30379,7 +30379,7 @@
           </a:solidFill>
           <a:ln w="9525">
             <a:solidFill>
-              <a:srgbClr val="13C2C2"/>
+              <a:srgbClr val="002060"/>
             </a:solidFill>
           </a:ln>
           <a:effectLst/>
@@ -30499,7 +30499,7 @@
           </a:solidFill>
           <a:ln w="9525">
             <a:solidFill>
-              <a:srgbClr val="13C2C2"/>
+              <a:srgbClr val="002060"/>
             </a:solidFill>
           </a:ln>
           <a:effectLst/>
@@ -30619,7 +30619,7 @@
           </a:solidFill>
           <a:ln w="9525">
             <a:solidFill>
-              <a:srgbClr val="13C2C2"/>
+              <a:srgbClr val="002060"/>
             </a:solidFill>
           </a:ln>
           <a:effectLst/>
@@ -30739,7 +30739,7 @@
           </a:solidFill>
           <a:ln w="9525">
             <a:solidFill>
-              <a:srgbClr val="13C2C2"/>
+              <a:srgbClr val="002060"/>
             </a:solidFill>
           </a:ln>
           <a:effectLst/>

</xml_diff>